<commit_message>
Loosen presentation spacing for breathing room
Bump default line spacing (1.3 for add_text, 1.35 for add_rich) and
enlarge the blank-line spacers between section headers and bodies,
between display equations and surrounding prose, and between bullet
groups. Keeps the editorial feel while letting each block of text
breathe.
</commit_message>
<xml_diff>
--- a/STAT 4830 Presentation.pptx
+++ b/STAT 4830 Presentation.pptx
@@ -3168,7 +3168,7 @@
           <a:p>
             <a:pPr algn="l">
               <a:lnSpc>
-                <a:spcPct val="115000"/>
+                <a:spcPct val="130000"/>
               </a:lnSpc>
             </a:pPr>
             <a:r>
@@ -3320,7 +3320,7 @@
           <a:p>
             <a:pPr algn="l">
               <a:lnSpc>
-                <a:spcPct val="120000"/>
+                <a:spcPct val="135000"/>
               </a:lnSpc>
             </a:pPr>
             <a:r>
@@ -3403,7 +3403,7 @@
           <a:p>
             <a:pPr algn="l">
               <a:lnSpc>
-                <a:spcPct val="115000"/>
+                <a:spcPct val="130000"/>
               </a:lnSpc>
             </a:pPr>
             <a:r>
@@ -3486,7 +3486,7 @@
           <a:p>
             <a:pPr algn="l">
               <a:lnSpc>
-                <a:spcPct val="115000"/>
+                <a:spcPct val="130000"/>
               </a:lnSpc>
             </a:pPr>
             <a:r>
@@ -3569,7 +3569,7 @@
           <a:p>
             <a:pPr algn="l">
               <a:lnSpc>
-                <a:spcPct val="115000"/>
+                <a:spcPct val="130000"/>
               </a:lnSpc>
             </a:pPr>
             <a:r>
@@ -3652,7 +3652,7 @@
           <a:p>
             <a:pPr algn="l">
               <a:lnSpc>
-                <a:spcPct val="115000"/>
+                <a:spcPct val="130000"/>
               </a:lnSpc>
             </a:pPr>
             <a:r>
@@ -3797,7 +3797,7 @@
           <a:p>
             <a:pPr algn="l">
               <a:lnSpc>
-                <a:spcPct val="115000"/>
+                <a:spcPct val="130000"/>
               </a:lnSpc>
             </a:pPr>
             <a:r>
@@ -3836,7 +3836,7 @@
           <a:p>
             <a:pPr algn="l">
               <a:lnSpc>
-                <a:spcPct val="115000"/>
+                <a:spcPct val="130000"/>
               </a:lnSpc>
             </a:pPr>
             <a:r>
@@ -3895,7 +3895,7 @@
         <p:spPr>
           <a:xfrm>
             <a:off x="548640" y="1645920"/>
-            <a:ext cx="5852160" cy="4572000"/>
+            <a:ext cx="5852160" cy="4754880"/>
           </a:xfrm>
           <a:prstGeom prst="rect">
             <a:avLst/>
@@ -3910,7 +3910,7 @@
           <a:p>
             <a:pPr algn="l">
               <a:lnSpc>
-                <a:spcPct val="120000"/>
+                <a:spcPct val="135000"/>
               </a:lnSpc>
             </a:pPr>
             <a:r>
@@ -3926,270 +3926,302 @@
           <a:p>
             <a:pPr algn="l">
               <a:lnSpc>
-                <a:spcPct val="120000"/>
+                <a:spcPct val="135000"/>
               </a:lnSpc>
             </a:pPr>
             <a:r>
-              <a:rPr sz="1700" b="0" i="1">
-                <a:solidFill>
-                  <a:srgbClr val="1C1917"/>
-                </a:solidFill>
-                <a:latin typeface="Georgia"/>
-              </a:rPr>
-              <a:t>(g ∗ g)(x)   ≤   (a ∗ a)(x)  +  2ε  +  ε²</a:t>
+              <a:rPr sz="400" b="0" i="0">
+                <a:solidFill>
+                  <a:srgbClr val="1C1917"/>
+                </a:solidFill>
+                <a:latin typeface="Calibri"/>
+              </a:rPr>
+              <a:t/>
             </a:r>
           </a:p>
           <a:p>
             <a:pPr algn="l">
               <a:lnSpc>
-                <a:spcPct val="120000"/>
+                <a:spcPct val="135000"/>
               </a:lnSpc>
             </a:pPr>
             <a:r>
-              <a:rPr sz="1400" b="0" i="0">
-                <a:solidFill>
-                  <a:srgbClr val="1C1917"/>
-                </a:solidFill>
-                <a:latin typeface="Calibri"/>
-              </a:rPr>
-              <a:t>where  </a:t>
-            </a:r>
-            <a:r>
-              <a:rPr sz="1400" b="0" i="1">
+              <a:rPr sz="1700" b="0" i="1">
                 <a:solidFill>
                   <a:srgbClr val="1C1917"/>
                 </a:solidFill>
                 <a:latin typeface="Georgia"/>
               </a:rPr>
-              <a:t>ε</a:t>
-            </a:r>
-            <a:r>
-              <a:rPr sz="1400" b="0" i="0">
-                <a:solidFill>
-                  <a:srgbClr val="1C1917"/>
-                </a:solidFill>
-                <a:latin typeface="Calibri"/>
-              </a:rPr>
-              <a:t>  is a bound on  </a:t>
-            </a:r>
-            <a:r>
-              <a:rPr sz="1400" b="0" i="1">
-                <a:solidFill>
-                  <a:srgbClr val="1C1917"/>
-                </a:solidFill>
-                <a:latin typeface="Georgia"/>
-              </a:rPr>
-              <a:t>‖g − a‖∞</a:t>
-            </a:r>
-            <a:r>
-              <a:rPr sz="1400" b="0" i="0">
-                <a:solidFill>
-                  <a:srgbClr val="1C1917"/>
-                </a:solidFill>
-                <a:latin typeface="Calibri"/>
-              </a:rPr>
-              <a:t>   (a  </a:t>
-            </a:r>
-            <a:r>
-              <a:rPr sz="1400" b="0" i="1">
-                <a:solidFill>
-                  <a:srgbClr val="1C1917"/>
-                </a:solidFill>
-                <a:latin typeface="Georgia"/>
-              </a:rPr>
-              <a:t>height</a:t>
-            </a:r>
-            <a:r>
-              <a:rPr sz="1400" b="0" i="0">
-                <a:solidFill>
-                  <a:srgbClr val="1C1917"/>
-                </a:solidFill>
-                <a:latin typeface="Calibri"/>
-              </a:rPr>
-              <a:t>   difference).</a:t>
+              <a:t>(g ∗ g)(x)   ≤   (a ∗ a)(x)  +  2ε  +  ε²</a:t>
             </a:r>
           </a:p>
           <a:p>
             <a:pPr algn="l">
               <a:lnSpc>
-                <a:spcPct val="120000"/>
+                <a:spcPct val="135000"/>
               </a:lnSpc>
             </a:pPr>
             <a:r>
-              <a:rPr sz="800" b="0" i="0">
-                <a:solidFill>
-                  <a:srgbClr val="1C1917"/>
-                </a:solidFill>
-                <a:latin typeface="Calibri"/>
-              </a:rPr>
-              <a:t/>
+              <a:rPr sz="1400" b="0" i="0">
+                <a:solidFill>
+                  <a:srgbClr val="1C1917"/>
+                </a:solidFill>
+                <a:latin typeface="Calibri"/>
+              </a:rPr>
+              <a:t>where  </a:t>
+            </a:r>
+            <a:r>
+              <a:rPr sz="1400" b="0" i="1">
+                <a:solidFill>
+                  <a:srgbClr val="1C1917"/>
+                </a:solidFill>
+                <a:latin typeface="Georgia"/>
+              </a:rPr>
+              <a:t>ε</a:t>
+            </a:r>
+            <a:r>
+              <a:rPr sz="1400" b="0" i="0">
+                <a:solidFill>
+                  <a:srgbClr val="1C1917"/>
+                </a:solidFill>
+                <a:latin typeface="Calibri"/>
+              </a:rPr>
+              <a:t>  is a bound on  </a:t>
+            </a:r>
+            <a:r>
+              <a:rPr sz="1400" b="0" i="1">
+                <a:solidFill>
+                  <a:srgbClr val="1C1917"/>
+                </a:solidFill>
+                <a:latin typeface="Georgia"/>
+              </a:rPr>
+              <a:t>‖g − a‖∞</a:t>
+            </a:r>
+            <a:r>
+              <a:rPr sz="1400" b="0" i="0">
+                <a:solidFill>
+                  <a:srgbClr val="1C1917"/>
+                </a:solidFill>
+                <a:latin typeface="Calibri"/>
+              </a:rPr>
+              <a:t>   (a  </a:t>
+            </a:r>
+            <a:r>
+              <a:rPr sz="1400" b="0" i="1">
+                <a:solidFill>
+                  <a:srgbClr val="1C1917"/>
+                </a:solidFill>
+                <a:latin typeface="Georgia"/>
+              </a:rPr>
+              <a:t>height</a:t>
+            </a:r>
+            <a:r>
+              <a:rPr sz="1400" b="0" i="0">
+                <a:solidFill>
+                  <a:srgbClr val="1C1917"/>
+                </a:solidFill>
+                <a:latin typeface="Calibri"/>
+              </a:rPr>
+              <a:t>   difference).</a:t>
             </a:r>
           </a:p>
           <a:p>
             <a:pPr algn="l">
               <a:lnSpc>
-                <a:spcPct val="120000"/>
+                <a:spcPct val="135000"/>
               </a:lnSpc>
             </a:pPr>
             <a:r>
-              <a:rPr sz="1500" b="1" i="0">
-                <a:solidFill>
-                  <a:srgbClr val="8E3A38"/>
-                </a:solidFill>
-                <a:latin typeface="Georgia"/>
-              </a:rPr>
-              <a:t>In the MATLAB code</a:t>
+              <a:rPr sz="1400" b="0" i="0">
+                <a:solidFill>
+                  <a:srgbClr val="1C1917"/>
+                </a:solidFill>
+                <a:latin typeface="Calibri"/>
+              </a:rPr>
+              <a:t/>
             </a:r>
           </a:p>
           <a:p>
             <a:pPr algn="l">
               <a:lnSpc>
-                <a:spcPct val="120000"/>
+                <a:spcPct val="135000"/>
               </a:lnSpc>
             </a:pPr>
             <a:r>
-              <a:rPr sz="1400" b="0" i="1">
-                <a:solidFill>
-                  <a:srgbClr val="1C1917"/>
+              <a:rPr sz="1500" b="1" i="0">
+                <a:solidFill>
+                  <a:srgbClr val="8E3A38"/>
                 </a:solidFill>
                 <a:latin typeface="Georgia"/>
               </a:rPr>
-              <a:t>ε = 0.02</a:t>
-            </a:r>
-            <a:r>
-              <a:rPr sz="1400" b="0" i="0">
-                <a:solidFill>
-                  <a:srgbClr val="1C1917"/>
-                </a:solidFill>
-                <a:latin typeface="Calibri"/>
-              </a:rPr>
-              <a:t>  (mass step),  but heights  </a:t>
-            </a:r>
-            <a:r>
-              <a:rPr sz="1400" b="0" i="1">
-                <a:solidFill>
-                  <a:srgbClr val="1C1917"/>
-                </a:solidFill>
-                <a:latin typeface="Georgia"/>
-              </a:rPr>
-              <a:t>hᵢ = 2d · massᵢ</a:t>
-            </a:r>
-            <a:r>
-              <a:rPr sz="1400" b="0" i="0">
-                <a:solidFill>
-                  <a:srgbClr val="1C1917"/>
-                </a:solidFill>
-                <a:latin typeface="Calibri"/>
-              </a:rPr>
-              <a:t>,</a:t>
+              <a:t>In the MATLAB code</a:t>
             </a:r>
           </a:p>
           <a:p>
             <a:pPr algn="l">
               <a:lnSpc>
-                <a:spcPct val="120000"/>
+                <a:spcPct val="135000"/>
               </a:lnSpc>
             </a:pPr>
             <a:r>
-              <a:rPr sz="1400" b="0" i="0">
-                <a:solidFill>
-                  <a:srgbClr val="1C1917"/>
-                </a:solidFill>
-                <a:latin typeface="Calibri"/>
-              </a:rPr>
-              <a:t>so the true  </a:t>
-            </a:r>
-            <a:r>
-              <a:rPr sz="1400" b="0" i="1">
-                <a:solidFill>
-                  <a:srgbClr val="1C1917"/>
-                </a:solidFill>
-                <a:latin typeface="Georgia"/>
-              </a:rPr>
-              <a:t>‖g − a‖∞</a:t>
-            </a:r>
-            <a:r>
-              <a:rPr sz="1400" b="0" i="0">
-                <a:solidFill>
-                  <a:srgbClr val="1C1917"/>
-                </a:solidFill>
-                <a:latin typeface="Calibri"/>
-              </a:rPr>
-              <a:t>  ≤  </a:t>
-            </a:r>
-            <a:r>
-              <a:rPr sz="1400" b="0" i="1">
-                <a:solidFill>
-                  <a:srgbClr val="1C1917"/>
-                </a:solidFill>
-                <a:latin typeface="Georgia"/>
-              </a:rPr>
-              <a:t>2d × 0.02</a:t>
-            </a:r>
-            <a:r>
-              <a:rPr sz="1400" b="0" i="0">
-                <a:solidFill>
-                  <a:srgbClr val="1C1917"/>
-                </a:solidFill>
-                <a:latin typeface="Calibri"/>
-              </a:rPr>
-              <a:t>,   not  </a:t>
-            </a:r>
-            <a:r>
-              <a:rPr sz="1400" b="0" i="1">
-                <a:solidFill>
-                  <a:srgbClr val="1C1917"/>
-                </a:solidFill>
-                <a:latin typeface="Georgia"/>
-              </a:rPr>
-              <a:t>0.02</a:t>
-            </a:r>
-            <a:r>
-              <a:rPr sz="1400" b="0" i="0">
-                <a:solidFill>
-                  <a:srgbClr val="1C1917"/>
-                </a:solidFill>
-                <a:latin typeface="Calibri"/>
-              </a:rPr>
-              <a:t>.</a:t>
+              <a:rPr sz="400" b="0" i="0">
+                <a:solidFill>
+                  <a:srgbClr val="1C1917"/>
+                </a:solidFill>
+                <a:latin typeface="Calibri"/>
+              </a:rPr>
+              <a:t/>
             </a:r>
           </a:p>
           <a:p>
             <a:pPr algn="l">
               <a:lnSpc>
-                <a:spcPct val="120000"/>
+                <a:spcPct val="135000"/>
               </a:lnSpc>
             </a:pPr>
             <a:r>
-              <a:rPr sz="1000" b="0" i="0">
-                <a:solidFill>
-                  <a:srgbClr val="1C1917"/>
-                </a:solidFill>
-                <a:latin typeface="Calibri"/>
-              </a:rPr>
-              <a:t/>
+              <a:rPr sz="1400" b="0" i="1">
+                <a:solidFill>
+                  <a:srgbClr val="1C1917"/>
+                </a:solidFill>
+                <a:latin typeface="Georgia"/>
+              </a:rPr>
+              <a:t>ε = 0.02</a:t>
+            </a:r>
+            <a:r>
+              <a:rPr sz="1400" b="0" i="0">
+                <a:solidFill>
+                  <a:srgbClr val="1C1917"/>
+                </a:solidFill>
+                <a:latin typeface="Calibri"/>
+              </a:rPr>
+              <a:t>  (mass step),  but heights  </a:t>
+            </a:r>
+            <a:r>
+              <a:rPr sz="1400" b="0" i="1">
+                <a:solidFill>
+                  <a:srgbClr val="1C1917"/>
+                </a:solidFill>
+                <a:latin typeface="Georgia"/>
+              </a:rPr>
+              <a:t>hᵢ = 2d · massᵢ</a:t>
+            </a:r>
+            <a:r>
+              <a:rPr sz="1400" b="0" i="0">
+                <a:solidFill>
+                  <a:srgbClr val="1C1917"/>
+                </a:solidFill>
+                <a:latin typeface="Calibri"/>
+              </a:rPr>
+              <a:t>,</a:t>
             </a:r>
           </a:p>
           <a:p>
             <a:pPr algn="l">
               <a:lnSpc>
-                <a:spcPct val="120000"/>
+                <a:spcPct val="135000"/>
               </a:lnSpc>
             </a:pPr>
             <a:r>
-              <a:rPr sz="1500" b="0" i="0">
-                <a:solidFill>
-                  <a:srgbClr val="1C1917"/>
-                </a:solidFill>
-                <a:latin typeface="Calibri"/>
-              </a:rPr>
-              <a:t>The code's pruning budget is too small by a factor of  </a:t>
+              <a:rPr sz="1400" b="0" i="0">
+                <a:solidFill>
+                  <a:srgbClr val="1C1917"/>
+                </a:solidFill>
+                <a:latin typeface="Calibri"/>
+              </a:rPr>
+              <a:t>so the true  </a:t>
+            </a:r>
+            <a:r>
+              <a:rPr sz="1400" b="0" i="1">
+                <a:solidFill>
+                  <a:srgbClr val="1C1917"/>
+                </a:solidFill>
+                <a:latin typeface="Georgia"/>
+              </a:rPr>
+              <a:t>‖g − a‖∞</a:t>
+            </a:r>
+            <a:r>
+              <a:rPr sz="1400" b="0" i="0">
+                <a:solidFill>
+                  <a:srgbClr val="1C1917"/>
+                </a:solidFill>
+                <a:latin typeface="Calibri"/>
+              </a:rPr>
+              <a:t>  ≤  </a:t>
+            </a:r>
+            <a:r>
+              <a:rPr sz="1400" b="0" i="1">
+                <a:solidFill>
+                  <a:srgbClr val="1C1917"/>
+                </a:solidFill>
+                <a:latin typeface="Georgia"/>
+              </a:rPr>
+              <a:t>2d × 0.02</a:t>
+            </a:r>
+            <a:r>
+              <a:rPr sz="1400" b="0" i="0">
+                <a:solidFill>
+                  <a:srgbClr val="1C1917"/>
+                </a:solidFill>
+                <a:latin typeface="Calibri"/>
+              </a:rPr>
+              <a:t>,   not  </a:t>
+            </a:r>
+            <a:r>
+              <a:rPr sz="1400" b="0" i="1">
+                <a:solidFill>
+                  <a:srgbClr val="1C1917"/>
+                </a:solidFill>
+                <a:latin typeface="Georgia"/>
+              </a:rPr>
+              <a:t>0.02</a:t>
+            </a:r>
+            <a:r>
+              <a:rPr sz="1400" b="0" i="0">
+                <a:solidFill>
+                  <a:srgbClr val="1C1917"/>
+                </a:solidFill>
+                <a:latin typeface="Calibri"/>
+              </a:rPr>
+              <a:t>.</a:t>
             </a:r>
           </a:p>
           <a:p>
             <a:pPr algn="l">
               <a:lnSpc>
-                <a:spcPct val="120000"/>
+                <a:spcPct val="135000"/>
+              </a:lnSpc>
+            </a:pPr>
+            <a:r>
+              <a:rPr sz="1600" b="0" i="0">
+                <a:solidFill>
+                  <a:srgbClr val="1C1917"/>
+                </a:solidFill>
+                <a:latin typeface="Calibri"/>
+              </a:rPr>
+              <a:t/>
+            </a:r>
+          </a:p>
+          <a:p>
+            <a:pPr algn="l">
+              <a:lnSpc>
+                <a:spcPct val="135000"/>
+              </a:lnSpc>
+            </a:pPr>
+            <a:r>
+              <a:rPr sz="1500" b="0" i="0">
+                <a:solidFill>
+                  <a:srgbClr val="1C1917"/>
+                </a:solidFill>
+                <a:latin typeface="Calibri"/>
+              </a:rPr>
+              <a:t>The code's pruning budget is too small by a factor of  </a:t>
+            </a:r>
+          </a:p>
+          <a:p>
+            <a:pPr algn="l">
+              <a:lnSpc>
+                <a:spcPct val="135000"/>
               </a:lnSpc>
             </a:pPr>
             <a:r>
@@ -4252,7 +4284,7 @@
           <a:p>
             <a:pPr algn="l">
               <a:lnSpc>
-                <a:spcPct val="115000"/>
+                <a:spcPct val="130000"/>
               </a:lnSpc>
             </a:pPr>
             <a:r>
@@ -4969,7 +5001,7 @@
           <a:p>
             <a:pPr algn="l">
               <a:lnSpc>
-                <a:spcPct val="115000"/>
+                <a:spcPct val="130000"/>
               </a:lnSpc>
             </a:pPr>
             <a:r>
@@ -5008,7 +5040,7 @@
           <a:p>
             <a:pPr algn="l">
               <a:lnSpc>
-                <a:spcPct val="115000"/>
+                <a:spcPct val="130000"/>
               </a:lnSpc>
             </a:pPr>
             <a:r>
@@ -5067,7 +5099,7 @@
         <p:spPr>
           <a:xfrm>
             <a:off x="548640" y="1645920"/>
-            <a:ext cx="5760720" cy="4572000"/>
+            <a:ext cx="5760720" cy="4754880"/>
           </a:xfrm>
           <a:prstGeom prst="rect">
             <a:avLst/>
@@ -5082,7 +5114,7 @@
           <a:p>
             <a:pPr algn="l">
               <a:lnSpc>
-                <a:spcPct val="120000"/>
+                <a:spcPct val="135000"/>
               </a:lnSpc>
             </a:pPr>
             <a:r>
@@ -5098,51 +5130,42 @@
           <a:p>
             <a:pPr algn="l">
               <a:lnSpc>
-                <a:spcPct val="120000"/>
+                <a:spcPct val="135000"/>
               </a:lnSpc>
             </a:pPr>
             <a:r>
-              <a:rPr sz="1400" b="0" i="0">
-                <a:solidFill>
-                  <a:srgbClr val="1C1917"/>
-                </a:solidFill>
-                <a:latin typeface="Calibri"/>
-              </a:rPr>
-              <a:t>Matolcsi–Vinuesa  (2010)  exhibit a continuous  </a:t>
-            </a:r>
-            <a:r>
-              <a:rPr sz="1400" b="0" i="1">
-                <a:solidFill>
-                  <a:srgbClr val="1C1917"/>
-                </a:solidFill>
-                <a:latin typeface="Georgia"/>
-              </a:rPr>
-              <a:t>f*</a:t>
-            </a:r>
-            <a:r>
-              <a:rPr sz="1400" b="0" i="0">
-                <a:solidFill>
-                  <a:srgbClr val="1C1917"/>
-                </a:solidFill>
-                <a:latin typeface="Calibri"/>
-              </a:rPr>
-              <a:t>  with</a:t>
+              <a:rPr sz="400" b="0" i="0">
+                <a:solidFill>
+                  <a:srgbClr val="1C1917"/>
+                </a:solidFill>
+                <a:latin typeface="Calibri"/>
+              </a:rPr>
+              <a:t/>
             </a:r>
           </a:p>
           <a:p>
             <a:pPr algn="l">
               <a:lnSpc>
-                <a:spcPct val="120000"/>
+                <a:spcPct val="135000"/>
               </a:lnSpc>
             </a:pPr>
             <a:r>
-              <a:rPr sz="1500" b="0" i="1">
+              <a:rPr sz="1400" b="0" i="0">
+                <a:solidFill>
+                  <a:srgbClr val="1C1917"/>
+                </a:solidFill>
+                <a:latin typeface="Calibri"/>
+              </a:rPr>
+              <a:t>Matolcsi–Vinuesa  (2010)  exhibit a continuous  </a:t>
+            </a:r>
+            <a:r>
+              <a:rPr sz="1400" b="0" i="1">
                 <a:solidFill>
                   <a:srgbClr val="1C1917"/>
                 </a:solidFill>
                 <a:latin typeface="Georgia"/>
               </a:rPr>
-              <a:t>‖f* ∗ f*‖∞  ≤  1.5029</a:t>
+              <a:t>f*</a:t>
             </a:r>
             <a:r>
               <a:rPr sz="1400" b="0" i="0">
@@ -5151,35 +5174,26 @@
                 </a:solidFill>
                 <a:latin typeface="Calibri"/>
               </a:rPr>
-              <a:t>.</a:t>
+              <a:t>  with</a:t>
             </a:r>
           </a:p>
           <a:p>
             <a:pPr algn="l">
               <a:lnSpc>
-                <a:spcPct val="120000"/>
+                <a:spcPct val="135000"/>
               </a:lnSpc>
             </a:pPr>
             <a:r>
+              <a:rPr sz="1500" b="0" i="1">
+                <a:solidFill>
+                  <a:srgbClr val="1C1917"/>
+                </a:solidFill>
+                <a:latin typeface="Georgia"/>
+              </a:rPr>
+              <a:t>‖f* ∗ f*‖∞  ≤  1.5029</a:t>
+            </a:r>
+            <a:r>
               <a:rPr sz="1400" b="0" i="0">
-                <a:solidFill>
-                  <a:srgbClr val="1C1917"/>
-                </a:solidFill>
-                <a:latin typeface="Calibri"/>
-              </a:rPr>
-              <a:t>So  </a:t>
-            </a:r>
-            <a:r>
-              <a:rPr sz="1400" b="0" i="1">
-                <a:solidFill>
-                  <a:srgbClr val="1C1917"/>
-                </a:solidFill>
-                <a:latin typeface="Georgia"/>
-              </a:rPr>
-              <a:t>C₁ₐ ≤ 1.5029</a:t>
-            </a:r>
-            <a:r>
-              <a:rPr sz="1400" b="0" i="1">
                 <a:solidFill>
                   <a:srgbClr val="1C1917"/>
                 </a:solidFill>
@@ -5191,23 +5205,41 @@
           <a:p>
             <a:pPr algn="l">
               <a:lnSpc>
-                <a:spcPct val="120000"/>
+                <a:spcPct val="135000"/>
               </a:lnSpc>
             </a:pPr>
             <a:r>
-              <a:rPr sz="800" b="0" i="0">
-                <a:solidFill>
-                  <a:srgbClr val="1C1917"/>
-                </a:solidFill>
-                <a:latin typeface="Calibri"/>
-              </a:rPr>
-              <a:t/>
+              <a:rPr sz="1400" b="0" i="0">
+                <a:solidFill>
+                  <a:srgbClr val="1C1917"/>
+                </a:solidFill>
+                <a:latin typeface="Calibri"/>
+              </a:rPr>
+              <a:t>So  </a:t>
+            </a:r>
+            <a:r>
+              <a:rPr sz="1400" b="0" i="1">
+                <a:solidFill>
+                  <a:srgbClr val="1C1917"/>
+                </a:solidFill>
+                <a:latin typeface="Georgia"/>
+              </a:rPr>
+              <a:t>C₁ₐ ≤ 1.5029</a:t>
+            </a:r>
+            <a:r>
+              <a:rPr sz="1400" b="0" i="1">
+                <a:solidFill>
+                  <a:srgbClr val="1C1917"/>
+                </a:solidFill>
+                <a:latin typeface="Calibri"/>
+              </a:rPr>
+              <a:t>.</a:t>
             </a:r>
           </a:p>
           <a:p>
             <a:pPr algn="l">
               <a:lnSpc>
-                <a:spcPct val="120000"/>
+                <a:spcPct val="135000"/>
               </a:lnSpc>
             </a:pPr>
             <a:r>
@@ -5217,47 +5249,47 @@
                 </a:solidFill>
                 <a:latin typeface="Calibri"/>
               </a:rPr>
-              <a:t>Point the MATLAB cascade at the threshold  </a:t>
-            </a:r>
-            <a:r>
-              <a:rPr sz="1400" b="0" i="1">
-                <a:solidFill>
-                  <a:srgbClr val="1C1917"/>
-                </a:solidFill>
-                <a:latin typeface="Georgia"/>
-              </a:rPr>
-              <a:t>1.51</a:t>
-            </a:r>
-            <a:r>
-              <a:rPr sz="1400" b="0" i="0">
-                <a:solidFill>
-                  <a:srgbClr val="1C1917"/>
-                </a:solidFill>
-                <a:latin typeface="Calibri"/>
-              </a:rPr>
-              <a:t>:</a:t>
+              <a:t/>
             </a:r>
           </a:p>
           <a:p>
             <a:pPr algn="l">
               <a:lnSpc>
-                <a:spcPct val="120000"/>
+                <a:spcPct val="135000"/>
               </a:lnSpc>
             </a:pPr>
             <a:r>
-              <a:rPr sz="1300" b="0" i="0">
-                <a:solidFill>
-                  <a:srgbClr val="1C1917"/>
-                </a:solidFill>
-                <a:latin typeface="Calibri"/>
-              </a:rPr>
-              <a:t>·  interior-window budget stays at  ≈ 0.04  across levels</a:t>
+              <a:rPr sz="1400" b="0" i="0">
+                <a:solidFill>
+                  <a:srgbClr val="1C1917"/>
+                </a:solidFill>
+                <a:latin typeface="Calibri"/>
+              </a:rPr>
+              <a:t>Point the MATLAB cascade at the threshold  </a:t>
+            </a:r>
+            <a:r>
+              <a:rPr sz="1400" b="0" i="1">
+                <a:solidFill>
+                  <a:srgbClr val="1C1917"/>
+                </a:solidFill>
+                <a:latin typeface="Georgia"/>
+              </a:rPr>
+              <a:t>1.51</a:t>
+            </a:r>
+            <a:r>
+              <a:rPr sz="1400" b="0" i="0">
+                <a:solidFill>
+                  <a:srgbClr val="1C1917"/>
+                </a:solidFill>
+                <a:latin typeface="Calibri"/>
+              </a:rPr>
+              <a:t>:</a:t>
             </a:r>
           </a:p>
           <a:p>
             <a:pPr algn="l">
               <a:lnSpc>
-                <a:spcPct val="120000"/>
+                <a:spcPct val="135000"/>
               </a:lnSpc>
             </a:pPr>
             <a:r>
@@ -5267,31 +5299,13 @@
                 </a:solidFill>
                 <a:latin typeface="Calibri"/>
               </a:rPr>
-              <a:t>·  the step-function approximation of  </a:t>
-            </a:r>
-            <a:r>
-              <a:rPr sz="1300" b="0" i="1">
-                <a:solidFill>
-                  <a:srgbClr val="1C1917"/>
-                </a:solidFill>
-                <a:latin typeface="Georgia"/>
-              </a:rPr>
-              <a:t>f*</a:t>
-            </a:r>
-            <a:r>
-              <a:rPr sz="1300" b="0" i="0">
-                <a:solidFill>
-                  <a:srgbClr val="1C1917"/>
-                </a:solidFill>
-                <a:latin typeface="Calibri"/>
-              </a:rPr>
-              <a:t>  has self-convolution peaks</a:t>
+              <a:t>·  interior-window budget stays at  ≈ 0.04  across levels</a:t>
             </a:r>
           </a:p>
           <a:p>
             <a:pPr algn="l">
               <a:lnSpc>
-                <a:spcPct val="120000"/>
+                <a:spcPct val="135000"/>
               </a:lnSpc>
             </a:pPr>
             <a:r>
@@ -5301,7 +5315,7 @@
                 </a:solidFill>
                 <a:latin typeface="Calibri"/>
               </a:rPr>
-              <a:t>   that exceed 1.55 on narrow windows at moderate  </a:t>
+              <a:t>·  the step-function approximation of  </a:t>
             </a:r>
             <a:r>
               <a:rPr sz="1300" b="0" i="1">
@@ -5310,13 +5324,22 @@
                 </a:solidFill>
                 <a:latin typeface="Georgia"/>
               </a:rPr>
-              <a:t>d</a:t>
+              <a:t>f*</a:t>
+            </a:r>
+            <a:r>
+              <a:rPr sz="1300" b="0" i="0">
+                <a:solidFill>
+                  <a:srgbClr val="1C1917"/>
+                </a:solidFill>
+                <a:latin typeface="Calibri"/>
+              </a:rPr>
+              <a:t>  has self-convolution peaks</a:t>
             </a:r>
           </a:p>
           <a:p>
             <a:pPr algn="l">
               <a:lnSpc>
-                <a:spcPct val="120000"/>
+                <a:spcPct val="135000"/>
               </a:lnSpc>
             </a:pPr>
             <a:r>
@@ -5326,7 +5349,7 @@
                 </a:solidFill>
                 <a:latin typeface="Calibri"/>
               </a:rPr>
-              <a:t>·  the code therefore prunes every descendant of  </a:t>
+              <a:t>   that exceed 1.55 on narrow windows at moderate  </a:t>
             </a:r>
             <a:r>
               <a:rPr sz="1300" b="0" i="1">
@@ -5335,13 +5358,13 @@
                 </a:solidFill>
                 <a:latin typeface="Georgia"/>
               </a:rPr>
-              <a:t>f*</a:t>
+              <a:t>d</a:t>
             </a:r>
           </a:p>
           <a:p>
             <a:pPr algn="l">
               <a:lnSpc>
-                <a:spcPct val="120000"/>
+                <a:spcPct val="135000"/>
               </a:lnSpc>
             </a:pPr>
             <a:r>
@@ -5351,38 +5374,63 @@
                 </a:solidFill>
                 <a:latin typeface="Calibri"/>
               </a:rPr>
-              <a:t>·  exhausted survivors  →  claim:  </a:t>
-            </a:r>
-            <a:r>
-              <a:rPr sz="1300" b="1" i="1">
+              <a:t>·  the code therefore prunes every descendant of  </a:t>
+            </a:r>
+            <a:r>
+              <a:rPr sz="1300" b="0" i="1">
                 <a:solidFill>
                   <a:srgbClr val="1C1917"/>
                 </a:solidFill>
                 <a:latin typeface="Georgia"/>
               </a:rPr>
-              <a:t>C₁ₐ ≥ 1.51</a:t>
+              <a:t>f*</a:t>
             </a:r>
           </a:p>
           <a:p>
             <a:pPr algn="l">
               <a:lnSpc>
-                <a:spcPct val="120000"/>
+                <a:spcPct val="135000"/>
               </a:lnSpc>
             </a:pPr>
             <a:r>
-              <a:rPr sz="800" b="0" i="0">
-                <a:solidFill>
-                  <a:srgbClr val="1C1917"/>
-                </a:solidFill>
-                <a:latin typeface="Calibri"/>
-              </a:rPr>
-              <a:t/>
+              <a:rPr sz="1300" b="0" i="0">
+                <a:solidFill>
+                  <a:srgbClr val="1C1917"/>
+                </a:solidFill>
+                <a:latin typeface="Calibri"/>
+              </a:rPr>
+              <a:t>·  exhausted survivors  →  claim:  </a:t>
+            </a:r>
+            <a:r>
+              <a:rPr sz="1300" b="1" i="1">
+                <a:solidFill>
+                  <a:srgbClr val="1C1917"/>
+                </a:solidFill>
+                <a:latin typeface="Georgia"/>
+              </a:rPr>
+              <a:t>C₁ₐ ≥ 1.51</a:t>
             </a:r>
           </a:p>
           <a:p>
             <a:pPr algn="l">
               <a:lnSpc>
-                <a:spcPct val="120000"/>
+                <a:spcPct val="135000"/>
+              </a:lnSpc>
+            </a:pPr>
+            <a:r>
+              <a:rPr sz="1400" b="0" i="0">
+                <a:solidFill>
+                  <a:srgbClr val="1C1917"/>
+                </a:solidFill>
+                <a:latin typeface="Calibri"/>
+              </a:rPr>
+              <a:t/>
+            </a:r>
+          </a:p>
+          <a:p>
+            <a:pPr algn="l">
+              <a:lnSpc>
+                <a:spcPct val="135000"/>
               </a:lnSpc>
             </a:pPr>
             <a:r>
@@ -5498,7 +5546,7 @@
           <a:p>
             <a:pPr algn="l">
               <a:lnSpc>
-                <a:spcPct val="115000"/>
+                <a:spcPct val="130000"/>
               </a:lnSpc>
             </a:pPr>
             <a:r>
@@ -5537,7 +5585,7 @@
           <a:p>
             <a:pPr algn="l">
               <a:lnSpc>
-                <a:spcPct val="115000"/>
+                <a:spcPct val="130000"/>
               </a:lnSpc>
             </a:pPr>
             <a:r>
@@ -6254,7 +6302,7 @@
           <a:p>
             <a:pPr algn="l">
               <a:lnSpc>
-                <a:spcPct val="115000"/>
+                <a:spcPct val="130000"/>
               </a:lnSpc>
             </a:pPr>
             <a:r>
@@ -6293,7 +6341,7 @@
           <a:p>
             <a:pPr algn="l">
               <a:lnSpc>
-                <a:spcPct val="115000"/>
+                <a:spcPct val="130000"/>
               </a:lnSpc>
             </a:pPr>
             <a:r>
@@ -6367,7 +6415,7 @@
           <a:p>
             <a:pPr algn="l">
               <a:lnSpc>
-                <a:spcPct val="115000"/>
+                <a:spcPct val="130000"/>
               </a:lnSpc>
             </a:pPr>
             <a:r>
@@ -6426,7 +6474,7 @@
         <p:spPr>
           <a:xfrm>
             <a:off x="548640" y="2194560"/>
-            <a:ext cx="5394960" cy="3840480"/>
+            <a:ext cx="5394960" cy="4023360"/>
           </a:xfrm>
           <a:prstGeom prst="rect">
             <a:avLst/>
@@ -6441,7 +6489,7 @@
           <a:p>
             <a:pPr algn="l">
               <a:lnSpc>
-                <a:spcPct val="120000"/>
+                <a:spcPct val="135000"/>
               </a:lnSpc>
             </a:pPr>
             <a:r>
@@ -6484,7 +6532,7 @@
           <a:p>
             <a:pPr algn="l">
               <a:lnSpc>
-                <a:spcPct val="120000"/>
+                <a:spcPct val="135000"/>
               </a:lnSpc>
             </a:pPr>
             <a:r>
@@ -6518,11 +6566,11 @@
           <a:p>
             <a:pPr algn="l">
               <a:lnSpc>
-                <a:spcPct val="120000"/>
+                <a:spcPct val="135000"/>
               </a:lnSpc>
             </a:pPr>
             <a:r>
-              <a:rPr sz="600" b="0" i="0">
+              <a:rPr sz="1000" b="0" i="0">
                 <a:solidFill>
                   <a:srgbClr val="1C1917"/>
                 </a:solidFill>
@@ -6534,7 +6582,7 @@
           <a:p>
             <a:pPr algn="l">
               <a:lnSpc>
-                <a:spcPct val="120000"/>
+                <a:spcPct val="135000"/>
               </a:lnSpc>
             </a:pPr>
             <a:r>
@@ -6568,11 +6616,11 @@
           <a:p>
             <a:pPr algn="l">
               <a:lnSpc>
-                <a:spcPct val="120000"/>
+                <a:spcPct val="135000"/>
               </a:lnSpc>
             </a:pPr>
             <a:r>
-              <a:rPr sz="1000" b="0" i="0">
+              <a:rPr sz="1400" b="0" i="0">
                 <a:solidFill>
                   <a:srgbClr val="1C1917"/>
                 </a:solidFill>
@@ -6584,7 +6632,7 @@
           <a:p>
             <a:pPr algn="l">
               <a:lnSpc>
-                <a:spcPct val="120000"/>
+                <a:spcPct val="135000"/>
               </a:lnSpc>
             </a:pPr>
             <a:r>
@@ -6600,7 +6648,7 @@
           <a:p>
             <a:pPr algn="l">
               <a:lnSpc>
-                <a:spcPct val="120000"/>
+                <a:spcPct val="135000"/>
               </a:lnSpc>
             </a:pPr>
             <a:r>
@@ -6616,7 +6664,7 @@
           <a:p>
             <a:pPr algn="l">
               <a:lnSpc>
-                <a:spcPct val="120000"/>
+                <a:spcPct val="135000"/>
               </a:lnSpc>
             </a:pPr>
             <a:r>
@@ -6632,7 +6680,7 @@
           <a:p>
             <a:pPr algn="l">
               <a:lnSpc>
-                <a:spcPct val="120000"/>
+                <a:spcPct val="135000"/>
               </a:lnSpc>
             </a:pPr>
             <a:r>
@@ -6648,7 +6696,7 @@
           <a:p>
             <a:pPr algn="l">
               <a:lnSpc>
-                <a:spcPct val="120000"/>
+                <a:spcPct val="135000"/>
               </a:lnSpc>
             </a:pPr>
             <a:r>
@@ -6687,7 +6735,7 @@
           <a:p>
             <a:pPr algn="l">
               <a:lnSpc>
-                <a:spcPct val="115000"/>
+                <a:spcPct val="130000"/>
               </a:lnSpc>
             </a:pPr>
             <a:r>
@@ -6746,7 +6794,7 @@
         <p:spPr>
           <a:xfrm>
             <a:off x="6355080" y="2194560"/>
-            <a:ext cx="5394960" cy="3840480"/>
+            <a:ext cx="5394960" cy="4023360"/>
           </a:xfrm>
           <a:prstGeom prst="rect">
             <a:avLst/>
@@ -6761,7 +6809,7 @@
           <a:p>
             <a:pPr algn="l">
               <a:lnSpc>
-                <a:spcPct val="120000"/>
+                <a:spcPct val="135000"/>
               </a:lnSpc>
             </a:pPr>
             <a:r>
@@ -6777,23 +6825,23 @@
           <a:p>
             <a:pPr algn="l">
               <a:lnSpc>
-                <a:spcPct val="120000"/>
+                <a:spcPct val="135000"/>
               </a:lnSpc>
             </a:pPr>
             <a:r>
-              <a:rPr sz="1300" b="0" i="0">
-                <a:solidFill>
-                  <a:srgbClr val="1C1917"/>
-                </a:solidFill>
-                <a:latin typeface="Calibri"/>
-              </a:rPr>
-              <a:t>The published bound was run on a separate fine-grid</a:t>
+              <a:rPr sz="400" b="0" i="0">
+                <a:solidFill>
+                  <a:srgbClr val="1C1917"/>
+                </a:solidFill>
+                <a:latin typeface="Calibri"/>
+              </a:rPr>
+              <a:t/>
             </a:r>
           </a:p>
           <a:p>
             <a:pPr algn="l">
               <a:lnSpc>
-                <a:spcPct val="120000"/>
+                <a:spcPct val="135000"/>
               </a:lnSpc>
             </a:pPr>
             <a:r>
@@ -6803,13 +6851,13 @@
                 </a:solidFill>
                 <a:latin typeface="Calibri"/>
               </a:rPr>
-              <a:t>enumerator;  the coarse-mass file is a speed-oriented</a:t>
+              <a:t>The published bound was run on a separate fine-grid</a:t>
             </a:r>
           </a:p>
           <a:p>
             <a:pPr algn="l">
               <a:lnSpc>
-                <a:spcPct val="120000"/>
+                <a:spcPct val="135000"/>
               </a:lnSpc>
             </a:pPr>
             <a:r>
@@ -6819,111 +6867,143 @@
                 </a:solidFill>
                 <a:latin typeface="Calibri"/>
               </a:rPr>
-              <a:t>variant never meant to be the proof vehicle.</a:t>
+              <a:t>enumerator;  the coarse-mass file is a speed-oriented</a:t>
             </a:r>
           </a:p>
           <a:p>
             <a:pPr algn="l">
               <a:lnSpc>
-                <a:spcPct val="120000"/>
+                <a:spcPct val="135000"/>
               </a:lnSpc>
             </a:pPr>
             <a:r>
-              <a:rPr sz="1000" b="0" i="0">
-                <a:solidFill>
-                  <a:srgbClr val="1C1917"/>
-                </a:solidFill>
-                <a:latin typeface="Calibri"/>
-              </a:rPr>
-              <a:t/>
+              <a:rPr sz="1300" b="0" i="0">
+                <a:solidFill>
+                  <a:srgbClr val="1C1917"/>
+                </a:solidFill>
+                <a:latin typeface="Calibri"/>
+              </a:rPr>
+              <a:t>variant never meant to be the proof vehicle.</a:t>
             </a:r>
           </a:p>
           <a:p>
             <a:pPr algn="l">
               <a:lnSpc>
-                <a:spcPct val="120000"/>
+                <a:spcPct val="135000"/>
               </a:lnSpc>
             </a:pPr>
             <a:r>
-              <a:rPr sz="1400" b="1" i="0">
-                <a:solidFill>
-                  <a:srgbClr val="1C1917"/>
-                </a:solidFill>
-                <a:latin typeface="Georgia"/>
-              </a:rPr>
-              <a:t>(b)  A derivation we're missing.</a:t>
+              <a:rPr sz="1400" b="0" i="0">
+                <a:solidFill>
+                  <a:srgbClr val="1C1917"/>
+                </a:solidFill>
+                <a:latin typeface="Calibri"/>
+              </a:rPr>
+              <a:t/>
             </a:r>
           </a:p>
           <a:p>
             <a:pPr algn="l">
               <a:lnSpc>
-                <a:spcPct val="120000"/>
+                <a:spcPct val="135000"/>
               </a:lnSpc>
             </a:pPr>
             <a:r>
-              <a:rPr sz="1300" b="0" i="0">
-                <a:solidFill>
-                  <a:srgbClr val="1C1917"/>
-                </a:solidFill>
-                <a:latin typeface="Calibri"/>
-              </a:rPr>
-              <a:t>A mass-space bound that avoids the  </a:t>
-            </a:r>
-            <a:r>
-              <a:rPr sz="1300" b="0" i="1">
+              <a:rPr sz="1400" b="1" i="0">
                 <a:solidFill>
                   <a:srgbClr val="1C1917"/>
                 </a:solidFill>
                 <a:latin typeface="Georgia"/>
               </a:rPr>
-              <a:t>2d</a:t>
-            </a:r>
-            <a:r>
-              <a:rPr sz="1300" b="0" i="0">
-                <a:solidFill>
-                  <a:srgbClr val="1C1917"/>
-                </a:solidFill>
-                <a:latin typeface="Calibri"/>
-              </a:rPr>
-              <a:t>  factor — </a:t>
+              <a:t>(b)  A derivation we're missing.</a:t>
             </a:r>
           </a:p>
           <a:p>
             <a:pPr algn="l">
               <a:lnSpc>
-                <a:spcPct val="120000"/>
+                <a:spcPct val="135000"/>
               </a:lnSpc>
             </a:pPr>
             <a:r>
-              <a:rPr sz="1300" b="0" i="0">
-                <a:solidFill>
-                  <a:srgbClr val="1C1917"/>
-                </a:solidFill>
-                <a:latin typeface="Calibri"/>
-              </a:rPr>
-              <a:t>unlikely, but worth asking about before we conclude.</a:t>
+              <a:rPr sz="400" b="0" i="0">
+                <a:solidFill>
+                  <a:srgbClr val="1C1917"/>
+                </a:solidFill>
+                <a:latin typeface="Calibri"/>
+              </a:rPr>
+              <a:t/>
             </a:r>
           </a:p>
           <a:p>
             <a:pPr algn="l">
               <a:lnSpc>
-                <a:spcPct val="120000"/>
+                <a:spcPct val="135000"/>
               </a:lnSpc>
             </a:pPr>
             <a:r>
-              <a:rPr sz="1000" b="0" i="0">
-                <a:solidFill>
-                  <a:srgbClr val="1C1917"/>
-                </a:solidFill>
-                <a:latin typeface="Calibri"/>
-              </a:rPr>
-              <a:t/>
+              <a:rPr sz="1300" b="0" i="0">
+                <a:solidFill>
+                  <a:srgbClr val="1C1917"/>
+                </a:solidFill>
+                <a:latin typeface="Calibri"/>
+              </a:rPr>
+              <a:t>A mass-space bound that avoids the  </a:t>
+            </a:r>
+            <a:r>
+              <a:rPr sz="1300" b="0" i="1">
+                <a:solidFill>
+                  <a:srgbClr val="1C1917"/>
+                </a:solidFill>
+                <a:latin typeface="Georgia"/>
+              </a:rPr>
+              <a:t>2d</a:t>
+            </a:r>
+            <a:r>
+              <a:rPr sz="1300" b="0" i="0">
+                <a:solidFill>
+                  <a:srgbClr val="1C1917"/>
+                </a:solidFill>
+                <a:latin typeface="Calibri"/>
+              </a:rPr>
+              <a:t>  factor — </a:t>
             </a:r>
           </a:p>
           <a:p>
             <a:pPr algn="l">
               <a:lnSpc>
-                <a:spcPct val="120000"/>
+                <a:spcPct val="135000"/>
+              </a:lnSpc>
+            </a:pPr>
+            <a:r>
+              <a:rPr sz="1300" b="0" i="0">
+                <a:solidFill>
+                  <a:srgbClr val="1C1917"/>
+                </a:solidFill>
+                <a:latin typeface="Calibri"/>
+              </a:rPr>
+              <a:t>unlikely, but worth asking about before we conclude.</a:t>
+            </a:r>
+          </a:p>
+          <a:p>
+            <a:pPr algn="l">
+              <a:lnSpc>
+                <a:spcPct val="135000"/>
+              </a:lnSpc>
+            </a:pPr>
+            <a:r>
+              <a:rPr sz="1400" b="0" i="0">
+                <a:solidFill>
+                  <a:srgbClr val="1C1917"/>
+                </a:solidFill>
+                <a:latin typeface="Calibri"/>
+              </a:rPr>
+              <a:t/>
+            </a:r>
+          </a:p>
+          <a:p>
+            <a:pPr algn="l">
+              <a:lnSpc>
+                <a:spcPct val="135000"/>
               </a:lnSpc>
             </a:pPr>
             <a:r>
@@ -6997,7 +7077,7 @@
           <a:p>
             <a:pPr algn="ctr">
               <a:lnSpc>
-                <a:spcPct val="115000"/>
+                <a:spcPct val="130000"/>
               </a:lnSpc>
             </a:pPr>
             <a:r>
@@ -7036,7 +7116,7 @@
           <a:p>
             <a:pPr algn="l">
               <a:lnSpc>
-                <a:spcPct val="115000"/>
+                <a:spcPct val="130000"/>
               </a:lnSpc>
             </a:pPr>
             <a:r>
@@ -7709,7 +7789,7 @@
           <a:p>
             <a:pPr algn="l">
               <a:lnSpc>
-                <a:spcPct val="115000"/>
+                <a:spcPct val="130000"/>
               </a:lnSpc>
             </a:pPr>
             <a:r>
@@ -7748,7 +7828,7 @@
           <a:p>
             <a:pPr algn="l">
               <a:lnSpc>
-                <a:spcPct val="115000"/>
+                <a:spcPct val="130000"/>
               </a:lnSpc>
             </a:pPr>
             <a:r>
@@ -7881,7 +7961,7 @@
           <a:p>
             <a:pPr algn="l">
               <a:lnSpc>
-                <a:spcPct val="115000"/>
+                <a:spcPct val="130000"/>
               </a:lnSpc>
             </a:pPr>
             <a:r>
@@ -7920,7 +8000,7 @@
           <a:p>
             <a:pPr algn="l">
               <a:lnSpc>
-                <a:spcPct val="120000"/>
+                <a:spcPct val="145000"/>
               </a:lnSpc>
             </a:pPr>
             <a:r>
@@ -7972,7 +8052,7 @@
           <a:p>
             <a:pPr algn="l">
               <a:lnSpc>
-                <a:spcPct val="120000"/>
+                <a:spcPct val="145000"/>
               </a:lnSpc>
             </a:pPr>
             <a:r>
@@ -8042,7 +8122,7 @@
           <a:p>
             <a:pPr algn="l">
               <a:lnSpc>
-                <a:spcPct val="120000"/>
+                <a:spcPct val="145000"/>
               </a:lnSpc>
             </a:pPr>
             <a:r>
@@ -8085,11 +8165,11 @@
           <a:p>
             <a:pPr algn="l">
               <a:lnSpc>
-                <a:spcPct val="120000"/>
+                <a:spcPct val="145000"/>
               </a:lnSpc>
             </a:pPr>
             <a:r>
-              <a:rPr sz="600" b="0" i="0">
+              <a:rPr sz="1200" b="0" i="0">
                 <a:solidFill>
                   <a:srgbClr val="1C1917"/>
                 </a:solidFill>
@@ -8101,7 +8181,7 @@
           <a:p>
             <a:pPr algn="l">
               <a:lnSpc>
-                <a:spcPct val="120000"/>
+                <a:spcPct val="145000"/>
               </a:lnSpc>
             </a:pPr>
             <a:r>
@@ -8158,7 +8238,7 @@
           <a:p>
             <a:pPr algn="l">
               <a:lnSpc>
-                <a:spcPct val="115000"/>
+                <a:spcPct val="130000"/>
               </a:lnSpc>
             </a:pPr>
             <a:r>
@@ -8831,7 +8911,7 @@
           <a:p>
             <a:pPr algn="l">
               <a:lnSpc>
-                <a:spcPct val="115000"/>
+                <a:spcPct val="130000"/>
               </a:lnSpc>
             </a:pPr>
             <a:r>
@@ -8870,7 +8950,7 @@
           <a:p>
             <a:pPr algn="l">
               <a:lnSpc>
-                <a:spcPct val="115000"/>
+                <a:spcPct val="130000"/>
               </a:lnSpc>
             </a:pPr>
             <a:r>
@@ -8929,7 +9009,7 @@
         <p:spPr>
           <a:xfrm>
             <a:off x="548640" y="1691640"/>
-            <a:ext cx="5760720" cy="2926080"/>
+            <a:ext cx="5760720" cy="3200400"/>
           </a:xfrm>
           <a:prstGeom prst="rect">
             <a:avLst/>
@@ -8944,7 +9024,7 @@
           <a:p>
             <a:pPr algn="l">
               <a:lnSpc>
-                <a:spcPct val="120000"/>
+                <a:spcPct val="135000"/>
               </a:lnSpc>
             </a:pPr>
             <a:r>
@@ -8996,7 +9076,7 @@
           <a:p>
             <a:pPr algn="l">
               <a:lnSpc>
-                <a:spcPct val="120000"/>
+                <a:spcPct val="135000"/>
               </a:lnSpc>
             </a:pPr>
             <a:r>
@@ -9030,11 +9110,11 @@
           <a:p>
             <a:pPr algn="l">
               <a:lnSpc>
-                <a:spcPct val="120000"/>
+                <a:spcPct val="135000"/>
               </a:lnSpc>
             </a:pPr>
             <a:r>
-              <a:rPr sz="1000" b="0" i="0">
+              <a:rPr sz="1600" b="0" i="0">
                 <a:solidFill>
                   <a:srgbClr val="1C1917"/>
                 </a:solidFill>
@@ -9046,7 +9126,7 @@
           <a:p>
             <a:pPr algn="l">
               <a:lnSpc>
-                <a:spcPct val="120000"/>
+                <a:spcPct val="135000"/>
               </a:lnSpc>
             </a:pPr>
             <a:r>
@@ -9062,11 +9142,11 @@
           <a:p>
             <a:pPr algn="l">
               <a:lnSpc>
-                <a:spcPct val="120000"/>
+                <a:spcPct val="135000"/>
               </a:lnSpc>
             </a:pPr>
             <a:r>
-              <a:rPr sz="1000" b="0" i="0">
+              <a:rPr sz="1800" b="0" i="0">
                 <a:solidFill>
                   <a:srgbClr val="1C1917"/>
                 </a:solidFill>
@@ -9078,7 +9158,7 @@
           <a:p>
             <a:pPr algn="l">
               <a:lnSpc>
-                <a:spcPct val="120000"/>
+                <a:spcPct val="135000"/>
               </a:lnSpc>
             </a:pPr>
             <a:r>
@@ -9094,7 +9174,7 @@
           <a:p>
             <a:pPr algn="l">
               <a:lnSpc>
-                <a:spcPct val="120000"/>
+                <a:spcPct val="135000"/>
               </a:lnSpc>
             </a:pPr>
             <a:r>
@@ -9110,7 +9190,7 @@
           <a:p>
             <a:pPr algn="l">
               <a:lnSpc>
-                <a:spcPct val="120000"/>
+                <a:spcPct val="135000"/>
               </a:lnSpc>
             </a:pPr>
             <a:r>
@@ -9208,7 +9288,7 @@
           <a:p>
             <a:pPr algn="l">
               <a:lnSpc>
-                <a:spcPct val="115000"/>
+                <a:spcPct val="130000"/>
               </a:lnSpc>
             </a:pPr>
             <a:r>
@@ -9247,7 +9327,7 @@
           <a:p>
             <a:pPr algn="l">
               <a:lnSpc>
-                <a:spcPct val="120000"/>
+                <a:spcPct val="135000"/>
               </a:lnSpc>
             </a:pPr>
             <a:r>
@@ -9331,7 +9411,7 @@
           <a:p>
             <a:pPr algn="l">
               <a:lnSpc>
-                <a:spcPct val="115000"/>
+                <a:spcPct val="130000"/>
               </a:lnSpc>
             </a:pPr>
             <a:r>
@@ -10048,7 +10128,7 @@
           <a:p>
             <a:pPr algn="l">
               <a:lnSpc>
-                <a:spcPct val="115000"/>
+                <a:spcPct val="130000"/>
               </a:lnSpc>
             </a:pPr>
             <a:r>
@@ -10087,7 +10167,7 @@
           <a:p>
             <a:pPr algn="l">
               <a:lnSpc>
-                <a:spcPct val="115000"/>
+                <a:spcPct val="130000"/>
               </a:lnSpc>
             </a:pPr>
             <a:r>
@@ -10161,7 +10241,7 @@
           <a:p>
             <a:pPr algn="l">
               <a:lnSpc>
-                <a:spcPct val="120000"/>
+                <a:spcPct val="130000"/>
               </a:lnSpc>
             </a:pPr>
             <a:r>
@@ -10177,7 +10257,7 @@
           <a:p>
             <a:pPr algn="l">
               <a:lnSpc>
-                <a:spcPct val="120000"/>
+                <a:spcPct val="130000"/>
               </a:lnSpc>
             </a:pPr>
             <a:r>
@@ -10247,11 +10327,11 @@
           <a:p>
             <a:pPr algn="l">
               <a:lnSpc>
-                <a:spcPct val="120000"/>
+                <a:spcPct val="130000"/>
               </a:lnSpc>
             </a:pPr>
             <a:r>
-              <a:rPr sz="600" b="0" i="0">
+              <a:rPr sz="1200" b="0" i="0">
                 <a:solidFill>
                   <a:srgbClr val="1C1917"/>
                 </a:solidFill>
@@ -10263,7 +10343,7 @@
           <a:p>
             <a:pPr algn="l">
               <a:lnSpc>
-                <a:spcPct val="120000"/>
+                <a:spcPct val="130000"/>
               </a:lnSpc>
             </a:pPr>
             <a:r>
@@ -10279,7 +10359,7 @@
           <a:p>
             <a:pPr algn="l">
               <a:lnSpc>
-                <a:spcPct val="120000"/>
+                <a:spcPct val="130000"/>
               </a:lnSpc>
             </a:pPr>
             <a:r>
@@ -10295,11 +10375,11 @@
           <a:p>
             <a:pPr algn="l">
               <a:lnSpc>
-                <a:spcPct val="120000"/>
+                <a:spcPct val="130000"/>
               </a:lnSpc>
             </a:pPr>
             <a:r>
-              <a:rPr sz="600" b="0" i="0">
+              <a:rPr sz="1200" b="0" i="0">
                 <a:solidFill>
                   <a:srgbClr val="1C1917"/>
                 </a:solidFill>
@@ -10311,7 +10391,7 @@
           <a:p>
             <a:pPr algn="l">
               <a:lnSpc>
-                <a:spcPct val="120000"/>
+                <a:spcPct val="130000"/>
               </a:lnSpc>
             </a:pPr>
             <a:r>
@@ -10327,7 +10407,7 @@
           <a:p>
             <a:pPr algn="l">
               <a:lnSpc>
-                <a:spcPct val="120000"/>
+                <a:spcPct val="130000"/>
               </a:lnSpc>
             </a:pPr>
             <a:r>
@@ -10343,11 +10423,11 @@
           <a:p>
             <a:pPr algn="l">
               <a:lnSpc>
-                <a:spcPct val="120000"/>
+                <a:spcPct val="130000"/>
               </a:lnSpc>
             </a:pPr>
             <a:r>
-              <a:rPr sz="600" b="0" i="0">
+              <a:rPr sz="1200" b="0" i="0">
                 <a:solidFill>
                   <a:srgbClr val="1C1917"/>
                 </a:solidFill>
@@ -10359,7 +10439,7 @@
           <a:p>
             <a:pPr algn="l">
               <a:lnSpc>
-                <a:spcPct val="120000"/>
+                <a:spcPct val="130000"/>
               </a:lnSpc>
             </a:pPr>
             <a:r>
@@ -10375,7 +10455,7 @@
           <a:p>
             <a:pPr algn="l">
               <a:lnSpc>
-                <a:spcPct val="120000"/>
+                <a:spcPct val="130000"/>
               </a:lnSpc>
             </a:pPr>
             <a:r>
@@ -10493,7 +10573,7 @@
           <a:p>
             <a:pPr algn="l">
               <a:lnSpc>
-                <a:spcPct val="115000"/>
+                <a:spcPct val="130000"/>
               </a:lnSpc>
             </a:pPr>
             <a:r>
@@ -10532,7 +10612,7 @@
           <a:p>
             <a:pPr algn="l">
               <a:lnSpc>
-                <a:spcPct val="120000"/>
+                <a:spcPct val="135000"/>
               </a:lnSpc>
             </a:pPr>
             <a:r>
@@ -10606,7 +10686,7 @@
           <a:p>
             <a:pPr algn="l">
               <a:lnSpc>
-                <a:spcPct val="115000"/>
+                <a:spcPct val="130000"/>
               </a:lnSpc>
             </a:pPr>
             <a:r>
@@ -10645,7 +10725,7 @@
           <a:p>
             <a:pPr algn="l">
               <a:lnSpc>
-                <a:spcPct val="115000"/>
+                <a:spcPct val="130000"/>
               </a:lnSpc>
             </a:pPr>
             <a:r>
@@ -10719,7 +10799,7 @@
           <a:p>
             <a:pPr algn="l">
               <a:lnSpc>
-                <a:spcPct val="115000"/>
+                <a:spcPct val="130000"/>
               </a:lnSpc>
             </a:pPr>
             <a:r>
@@ -10758,7 +10838,7 @@
           <a:p>
             <a:pPr algn="l">
               <a:lnSpc>
-                <a:spcPct val="115000"/>
+                <a:spcPct val="130000"/>
               </a:lnSpc>
             </a:pPr>
             <a:r>
@@ -11431,7 +11511,7 @@
           <a:p>
             <a:pPr algn="l">
               <a:lnSpc>
-                <a:spcPct val="115000"/>
+                <a:spcPct val="130000"/>
               </a:lnSpc>
             </a:pPr>
             <a:r>
@@ -11470,7 +11550,7 @@
           <a:p>
             <a:pPr algn="l">
               <a:lnSpc>
-                <a:spcPct val="115000"/>
+                <a:spcPct val="130000"/>
               </a:lnSpc>
             </a:pPr>
             <a:r>
@@ -11603,7 +11683,7 @@
           <a:p>
             <a:pPr algn="l">
               <a:lnSpc>
-                <a:spcPct val="120000"/>
+                <a:spcPct val="135000"/>
               </a:lnSpc>
             </a:pPr>
             <a:r>
@@ -11655,7 +11735,7 @@
           <a:p>
             <a:pPr algn="l">
               <a:lnSpc>
-                <a:spcPct val="120000"/>
+                <a:spcPct val="135000"/>
               </a:lnSpc>
             </a:pPr>
             <a:r>
@@ -11712,7 +11792,7 @@
           <a:p>
             <a:pPr algn="l">
               <a:lnSpc>
-                <a:spcPct val="115000"/>
+                <a:spcPct val="130000"/>
               </a:lnSpc>
             </a:pPr>
             <a:r>
@@ -12429,7 +12509,7 @@
           <a:p>
             <a:pPr algn="l">
               <a:lnSpc>
-                <a:spcPct val="115000"/>
+                <a:spcPct val="130000"/>
               </a:lnSpc>
             </a:pPr>
             <a:r>
@@ -12468,7 +12548,7 @@
           <a:p>
             <a:pPr algn="l">
               <a:lnSpc>
-                <a:spcPct val="115000"/>
+                <a:spcPct val="130000"/>
               </a:lnSpc>
             </a:pPr>
             <a:r>
@@ -12542,7 +12622,7 @@
           <a:p>
             <a:pPr algn="l">
               <a:lnSpc>
-                <a:spcPct val="120000"/>
+                <a:spcPct val="135000"/>
               </a:lnSpc>
             </a:pPr>
             <a:r>
@@ -12558,7 +12638,7 @@
           <a:p>
             <a:pPr algn="l">
               <a:lnSpc>
-                <a:spcPct val="120000"/>
+                <a:spcPct val="135000"/>
               </a:lnSpc>
             </a:pPr>
             <a:r>
@@ -12574,7 +12654,7 @@
           <a:p>
             <a:pPr algn="l">
               <a:lnSpc>
-                <a:spcPct val="120000"/>
+                <a:spcPct val="135000"/>
               </a:lnSpc>
             </a:pPr>
             <a:r>
@@ -12590,7 +12670,7 @@
           <a:p>
             <a:pPr algn="l">
               <a:lnSpc>
-                <a:spcPct val="120000"/>
+                <a:spcPct val="135000"/>
               </a:lnSpc>
             </a:pPr>
             <a:r>
@@ -12615,7 +12695,7 @@
           <a:p>
             <a:pPr algn="l">
               <a:lnSpc>
-                <a:spcPct val="120000"/>
+                <a:spcPct val="135000"/>
               </a:lnSpc>
             </a:pPr>
             <a:r>
@@ -12631,11 +12711,11 @@
           <a:p>
             <a:pPr algn="l">
               <a:lnSpc>
-                <a:spcPct val="120000"/>
+                <a:spcPct val="135000"/>
               </a:lnSpc>
             </a:pPr>
             <a:r>
-              <a:rPr sz="800" b="0" i="0">
+              <a:rPr sz="1600" b="0" i="0">
                 <a:solidFill>
                   <a:srgbClr val="1C1917"/>
                 </a:solidFill>
@@ -12647,7 +12727,7 @@
           <a:p>
             <a:pPr algn="l">
               <a:lnSpc>
-                <a:spcPct val="120000"/>
+                <a:spcPct val="135000"/>
               </a:lnSpc>
             </a:pPr>
             <a:r>
@@ -12663,7 +12743,7 @@
           <a:p>
             <a:pPr algn="l">
               <a:lnSpc>
-                <a:spcPct val="120000"/>
+                <a:spcPct val="135000"/>
               </a:lnSpc>
             </a:pPr>
             <a:r>
@@ -12679,7 +12759,7 @@
           <a:p>
             <a:pPr algn="l">
               <a:lnSpc>
-                <a:spcPct val="120000"/>
+                <a:spcPct val="135000"/>
               </a:lnSpc>
             </a:pPr>
             <a:r>
@@ -12695,7 +12775,7 @@
           <a:p>
             <a:pPr algn="l">
               <a:lnSpc>
-                <a:spcPct val="120000"/>
+                <a:spcPct val="135000"/>
               </a:lnSpc>
             </a:pPr>
             <a:r>
@@ -12711,7 +12791,7 @@
           <a:p>
             <a:pPr algn="l">
               <a:lnSpc>
-                <a:spcPct val="120000"/>
+                <a:spcPct val="135000"/>
               </a:lnSpc>
             </a:pPr>
             <a:r>
@@ -12727,7 +12807,7 @@
           <a:p>
             <a:pPr algn="l">
               <a:lnSpc>
-                <a:spcPct val="120000"/>
+                <a:spcPct val="135000"/>
               </a:lnSpc>
             </a:pPr>
             <a:r>
@@ -12790,7 +12870,7 @@
           <a:p>
             <a:pPr algn="l">
               <a:lnSpc>
-                <a:spcPct val="115000"/>
+                <a:spcPct val="130000"/>
               </a:lnSpc>
             </a:pPr>
             <a:r>
@@ -13507,7 +13587,7 @@
           <a:p>
             <a:pPr algn="l">
               <a:lnSpc>
-                <a:spcPct val="115000"/>
+                <a:spcPct val="130000"/>
               </a:lnSpc>
             </a:pPr>
             <a:r>
@@ -13546,7 +13626,7 @@
           <a:p>
             <a:pPr algn="l">
               <a:lnSpc>
-                <a:spcPct val="115000"/>
+                <a:spcPct val="130000"/>
               </a:lnSpc>
             </a:pPr>
             <a:r>
@@ -13620,7 +13700,7 @@
           <a:p>
             <a:pPr algn="l">
               <a:lnSpc>
-                <a:spcPct val="115000"/>
+                <a:spcPct val="130000"/>
               </a:lnSpc>
             </a:pPr>
             <a:r>
@@ -13733,7 +13813,7 @@
           <a:p>
             <a:pPr algn="l">
               <a:lnSpc>
-                <a:spcPct val="120000"/>
+                <a:spcPct val="135000"/>
               </a:lnSpc>
             </a:pPr>
             <a:r>
@@ -13758,7 +13838,7 @@
           <a:p>
             <a:pPr algn="l">
               <a:lnSpc>
-                <a:spcPct val="120000"/>
+                <a:spcPct val="135000"/>
               </a:lnSpc>
             </a:pPr>
             <a:r>
@@ -13832,7 +13912,7 @@
           <a:p>
             <a:pPr algn="l">
               <a:lnSpc>
-                <a:spcPct val="120000"/>
+                <a:spcPct val="135000"/>
               </a:lnSpc>
             </a:pPr>
             <a:r>
@@ -13848,7 +13928,7 @@
           <a:p>
             <a:pPr algn="l">
               <a:lnSpc>
-                <a:spcPct val="120000"/>
+                <a:spcPct val="135000"/>
               </a:lnSpc>
             </a:pPr>
             <a:r>
@@ -13922,7 +14002,7 @@
           <a:p>
             <a:pPr algn="l">
               <a:lnSpc>
-                <a:spcPct val="115000"/>
+                <a:spcPct val="130000"/>
               </a:lnSpc>
             </a:pPr>
             <a:r>
@@ -13961,7 +14041,7 @@
           <a:p>
             <a:pPr algn="l">
               <a:lnSpc>
-                <a:spcPct val="120000"/>
+                <a:spcPct val="135000"/>
               </a:lnSpc>
             </a:pPr>
             <a:r>
@@ -13977,11 +14057,11 @@
           <a:p>
             <a:pPr algn="l">
               <a:lnSpc>
-                <a:spcPct val="120000"/>
+                <a:spcPct val="135000"/>
               </a:lnSpc>
             </a:pPr>
             <a:r>
-              <a:rPr sz="600" b="0" i="0">
+              <a:rPr sz="1000" b="0" i="0">
                 <a:solidFill>
                   <a:srgbClr val="1C1917"/>
                 </a:solidFill>
@@ -13993,7 +14073,7 @@
           <a:p>
             <a:pPr algn="l">
               <a:lnSpc>
-                <a:spcPct val="120000"/>
+                <a:spcPct val="135000"/>
               </a:lnSpc>
             </a:pPr>
             <a:r>
@@ -14009,7 +14089,7 @@
           <a:p>
             <a:pPr algn="l">
               <a:lnSpc>
-                <a:spcPct val="120000"/>
+                <a:spcPct val="135000"/>
               </a:lnSpc>
             </a:pPr>
             <a:r>
@@ -14043,11 +14123,11 @@
           <a:p>
             <a:pPr algn="l">
               <a:lnSpc>
-                <a:spcPct val="120000"/>
+                <a:spcPct val="135000"/>
               </a:lnSpc>
             </a:pPr>
             <a:r>
-              <a:rPr sz="1000" b="0" i="0">
+              <a:rPr sz="1600" b="0" i="0">
                 <a:solidFill>
                   <a:srgbClr val="1C1917"/>
                 </a:solidFill>
@@ -14059,7 +14139,7 @@
           <a:p>
             <a:pPr algn="l">
               <a:lnSpc>
-                <a:spcPct val="120000"/>
+                <a:spcPct val="135000"/>
               </a:lnSpc>
             </a:pPr>
             <a:r>
@@ -14075,11 +14155,11 @@
           <a:p>
             <a:pPr algn="l">
               <a:lnSpc>
-                <a:spcPct val="120000"/>
+                <a:spcPct val="135000"/>
               </a:lnSpc>
             </a:pPr>
             <a:r>
-              <a:rPr sz="600" b="0" i="0">
+              <a:rPr sz="1000" b="0" i="0">
                 <a:solidFill>
                   <a:srgbClr val="1C1917"/>
                 </a:solidFill>
@@ -14091,7 +14171,7 @@
           <a:p>
             <a:pPr algn="l">
               <a:lnSpc>
-                <a:spcPct val="120000"/>
+                <a:spcPct val="135000"/>
               </a:lnSpc>
             </a:pPr>
             <a:r>
@@ -14125,7 +14205,7 @@
           <a:p>
             <a:pPr algn="l">
               <a:lnSpc>
-                <a:spcPct val="120000"/>
+                <a:spcPct val="135000"/>
               </a:lnSpc>
             </a:pPr>
             <a:r>
@@ -14141,7 +14221,7 @@
           <a:p>
             <a:pPr algn="l">
               <a:lnSpc>
-                <a:spcPct val="120000"/>
+                <a:spcPct val="135000"/>
               </a:lnSpc>
             </a:pPr>
             <a:r>
@@ -14180,7 +14260,7 @@
           <a:p>
             <a:pPr algn="l">
               <a:lnSpc>
-                <a:spcPct val="115000"/>
+                <a:spcPct val="130000"/>
               </a:lnSpc>
             </a:pPr>
             <a:r>
@@ -14897,7 +14977,7 @@
           <a:p>
             <a:pPr algn="l">
               <a:lnSpc>
-                <a:spcPct val="115000"/>
+                <a:spcPct val="130000"/>
               </a:lnSpc>
             </a:pPr>
             <a:r>
@@ -14936,7 +15016,7 @@
           <a:p>
             <a:pPr algn="l">
               <a:lnSpc>
-                <a:spcPct val="115000"/>
+                <a:spcPct val="130000"/>
               </a:lnSpc>
             </a:pPr>
             <a:r>
@@ -14994,7 +15074,7 @@
         </p:nvSpPr>
         <p:spPr>
           <a:xfrm>
-            <a:off x="548640" y="1645920"/>
+            <a:off x="548640" y="1600200"/>
             <a:ext cx="11064240" cy="457200"/>
           </a:xfrm>
           <a:prstGeom prst="rect">
@@ -15010,7 +15090,7 @@
           <a:p>
             <a:pPr algn="l">
               <a:lnSpc>
-                <a:spcPct val="120000"/>
+                <a:spcPct val="135000"/>
               </a:lnSpc>
             </a:pPr>
             <a:r>
@@ -15060,8 +15140,8 @@
         </p:nvSpPr>
         <p:spPr>
           <a:xfrm>
-            <a:off x="548640" y="2176272"/>
-            <a:ext cx="11064240" cy="685800"/>
+            <a:off x="548640" y="2194560"/>
+            <a:ext cx="11064240" cy="731520"/>
           </a:xfrm>
           <a:prstGeom prst="rect">
             <a:avLst/>
@@ -15104,7 +15184,7 @@
         </p:nvSpPr>
         <p:spPr>
           <a:xfrm>
-            <a:off x="548640" y="2267712"/>
+            <a:off x="548640" y="2286000"/>
             <a:ext cx="11064240" cy="548640"/>
           </a:xfrm>
           <a:prstGeom prst="rect">
@@ -15120,7 +15200,7 @@
           <a:p>
             <a:pPr algn="ctr">
               <a:lnSpc>
-                <a:spcPct val="115000"/>
+                <a:spcPct val="130000"/>
               </a:lnSpc>
             </a:pPr>
             <a:r>
@@ -15143,7 +15223,7 @@
         </p:nvSpPr>
         <p:spPr>
           <a:xfrm>
-            <a:off x="548640" y="3063240"/>
+            <a:off x="548640" y="3200400"/>
             <a:ext cx="11064240" cy="457200"/>
           </a:xfrm>
           <a:prstGeom prst="rect">
@@ -15159,7 +15239,7 @@
           <a:p>
             <a:pPr algn="l">
               <a:lnSpc>
-                <a:spcPct val="120000"/>
+                <a:spcPct val="135000"/>
               </a:lnSpc>
             </a:pPr>
             <a:r>
@@ -15191,8 +15271,8 @@
         </p:nvSpPr>
         <p:spPr>
           <a:xfrm>
-            <a:off x="548640" y="3593592"/>
-            <a:ext cx="11064240" cy="685800"/>
+            <a:off x="548640" y="3794760"/>
+            <a:ext cx="11064240" cy="731520"/>
           </a:xfrm>
           <a:prstGeom prst="rect">
             <a:avLst/>
@@ -15235,7 +15315,7 @@
         </p:nvSpPr>
         <p:spPr>
           <a:xfrm>
-            <a:off x="548640" y="3685032"/>
+            <a:off x="548640" y="3886200"/>
             <a:ext cx="11064240" cy="548640"/>
           </a:xfrm>
           <a:prstGeom prst="rect">
@@ -15251,7 +15331,7 @@
           <a:p>
             <a:pPr algn="ctr">
               <a:lnSpc>
-                <a:spcPct val="115000"/>
+                <a:spcPct val="130000"/>
               </a:lnSpc>
             </a:pPr>
             <a:r>
@@ -15274,7 +15354,7 @@
         </p:nvSpPr>
         <p:spPr>
           <a:xfrm>
-            <a:off x="548640" y="4480560"/>
+            <a:off x="548640" y="4800600"/>
             <a:ext cx="11064240" cy="457200"/>
           </a:xfrm>
           <a:prstGeom prst="rect">
@@ -15290,7 +15370,7 @@
           <a:p>
             <a:pPr algn="l">
               <a:lnSpc>
-                <a:spcPct val="120000"/>
+                <a:spcPct val="135000"/>
               </a:lnSpc>
             </a:pPr>
             <a:r>
@@ -15340,7 +15420,7 @@
         </p:nvCxnSpPr>
         <p:spPr>
           <a:xfrm>
-            <a:off x="548640" y="5349240"/>
+            <a:off x="548640" y="5532120"/>
             <a:ext cx="11064240" cy="0"/>
           </a:xfrm>
           <a:prstGeom prst="line">
@@ -15375,7 +15455,7 @@
         </p:nvSpPr>
         <p:spPr>
           <a:xfrm>
-            <a:off x="548640" y="5440680"/>
+            <a:off x="548640" y="5623560"/>
             <a:ext cx="11064240" cy="1097280"/>
           </a:xfrm>
           <a:prstGeom prst="rect">
@@ -15391,7 +15471,7 @@
           <a:p>
             <a:pPr algn="l">
               <a:lnSpc>
-                <a:spcPct val="120000"/>
+                <a:spcPct val="135000"/>
               </a:lnSpc>
             </a:pPr>
             <a:r>
@@ -15416,7 +15496,7 @@
           <a:p>
             <a:pPr algn="l">
               <a:lnSpc>
-                <a:spcPct val="120000"/>
+                <a:spcPct val="135000"/>
               </a:lnSpc>
             </a:pPr>
             <a:r>
@@ -15509,7 +15589,7 @@
           <a:p>
             <a:pPr algn="l">
               <a:lnSpc>
-                <a:spcPct val="115000"/>
+                <a:spcPct val="130000"/>
               </a:lnSpc>
             </a:pPr>
             <a:r>
@@ -16226,7 +16306,7 @@
           <a:p>
             <a:pPr algn="l">
               <a:lnSpc>
-                <a:spcPct val="115000"/>
+                <a:spcPct val="130000"/>
               </a:lnSpc>
             </a:pPr>
             <a:r>
@@ -16265,7 +16345,7 @@
           <a:p>
             <a:pPr algn="l">
               <a:lnSpc>
-                <a:spcPct val="115000"/>
+                <a:spcPct val="130000"/>
               </a:lnSpc>
             </a:pPr>
             <a:r>
@@ -16363,7 +16443,7 @@
           <a:p>
             <a:pPr algn="l">
               <a:lnSpc>
-                <a:spcPct val="115000"/>
+                <a:spcPct val="130000"/>
               </a:lnSpc>
             </a:pPr>
             <a:r>
@@ -16476,7 +16556,7 @@
           <a:p>
             <a:pPr algn="l">
               <a:lnSpc>
-                <a:spcPct val="120000"/>
+                <a:spcPct val="135000"/>
               </a:lnSpc>
             </a:pPr>
             <a:r>
@@ -16501,7 +16581,7 @@
           <a:p>
             <a:pPr algn="l">
               <a:lnSpc>
-                <a:spcPct val="120000"/>
+                <a:spcPct val="135000"/>
               </a:lnSpc>
             </a:pPr>
             <a:r>
@@ -16575,7 +16655,7 @@
           <a:p>
             <a:pPr algn="l">
               <a:lnSpc>
-                <a:spcPct val="120000"/>
+                <a:spcPct val="130000"/>
               </a:lnSpc>
             </a:pPr>
             <a:r>
@@ -16591,23 +16671,23 @@
           <a:p>
             <a:pPr algn="l">
               <a:lnSpc>
-                <a:spcPct val="120000"/>
+                <a:spcPct val="130000"/>
               </a:lnSpc>
             </a:pPr>
             <a:r>
-              <a:rPr sz="1200" b="0" i="0">
-                <a:solidFill>
-                  <a:srgbClr val="1C1917"/>
-                </a:solidFill>
-                <a:latin typeface="Calibri"/>
-              </a:rPr>
-              <a:t>·  a single dual-feasible point  (y, Z, Λ)</a:t>
+              <a:rPr sz="600" b="0" i="0">
+                <a:solidFill>
+                  <a:srgbClr val="1C1917"/>
+                </a:solidFill>
+                <a:latin typeface="Calibri"/>
+              </a:rPr>
+              <a:t/>
             </a:r>
           </a:p>
           <a:p>
             <a:pPr algn="l">
               <a:lnSpc>
-                <a:spcPct val="120000"/>
+                <a:spcPct val="130000"/>
               </a:lnSpc>
             </a:pPr>
             <a:r>
@@ -16617,13 +16697,13 @@
                 </a:solidFill>
                 <a:latin typeface="Calibri"/>
               </a:rPr>
-              <a:t>·  post-processed via Jansson–Chaykin–Keil</a:t>
+              <a:t>·  a single dual-feasible point  (y, Z, Λ)</a:t>
             </a:r>
           </a:p>
           <a:p>
             <a:pPr algn="l">
               <a:lnSpc>
-                <a:spcPct val="120000"/>
+                <a:spcPct val="130000"/>
               </a:lnSpc>
             </a:pPr>
             <a:r>
@@ -16633,13 +16713,13 @@
                 </a:solidFill>
                 <a:latin typeface="Calibri"/>
               </a:rPr>
-              <a:t>   interval-arithmetic shift</a:t>
+              <a:t>·  post-processed via Jansson–Chaykin–Keil</a:t>
             </a:r>
           </a:p>
           <a:p>
             <a:pPr algn="l">
               <a:lnSpc>
-                <a:spcPct val="120000"/>
+                <a:spcPct val="130000"/>
               </a:lnSpc>
             </a:pPr>
             <a:r>
@@ -16649,22 +16729,38 @@
                 </a:solidFill>
                 <a:latin typeface="Calibri"/>
               </a:rPr>
-              <a:t>·  auxiliary runs at  </a:t>
-            </a:r>
-            <a:r>
-              <a:rPr sz="1200" b="0" i="1">
-                <a:solidFill>
-                  <a:srgbClr val="1C1917"/>
-                </a:solidFill>
-                <a:latin typeface="Georgia"/>
-              </a:rPr>
-              <a:t>d ∈ {32, 64, 128}</a:t>
+              <a:t>   interval-arithmetic shift</a:t>
             </a:r>
           </a:p>
           <a:p>
             <a:pPr algn="l">
               <a:lnSpc>
-                <a:spcPct val="120000"/>
+                <a:spcPct val="130000"/>
+              </a:lnSpc>
+            </a:pPr>
+            <a:r>
+              <a:rPr sz="1200" b="0" i="0">
+                <a:solidFill>
+                  <a:srgbClr val="1C1917"/>
+                </a:solidFill>
+                <a:latin typeface="Calibri"/>
+              </a:rPr>
+              <a:t>·  auxiliary runs at  </a:t>
+            </a:r>
+            <a:r>
+              <a:rPr sz="1200" b="0" i="1">
+                <a:solidFill>
+                  <a:srgbClr val="1C1917"/>
+                </a:solidFill>
+                <a:latin typeface="Georgia"/>
+              </a:rPr>
+              <a:t>d ∈ {32, 64, 128}</a:t>
+            </a:r>
+          </a:p>
+          <a:p>
+            <a:pPr algn="l">
+              <a:lnSpc>
+                <a:spcPct val="130000"/>
               </a:lnSpc>
             </a:pPr>
             <a:r>
@@ -16703,7 +16799,7 @@
           <a:p>
             <a:pPr algn="l">
               <a:lnSpc>
-                <a:spcPct val="115000"/>
+                <a:spcPct val="130000"/>
               </a:lnSpc>
             </a:pPr>
             <a:r>
@@ -17420,7 +17516,7 @@
           <a:p>
             <a:pPr algn="l">
               <a:lnSpc>
-                <a:spcPct val="115000"/>
+                <a:spcPct val="130000"/>
               </a:lnSpc>
             </a:pPr>
             <a:r>
@@ -17459,7 +17555,7 @@
           <a:p>
             <a:pPr algn="l">
               <a:lnSpc>
-                <a:spcPct val="115000"/>
+                <a:spcPct val="130000"/>
               </a:lnSpc>
             </a:pPr>
             <a:r>
@@ -17533,7 +17629,7 @@
           <a:p>
             <a:pPr algn="l">
               <a:lnSpc>
-                <a:spcPct val="120000"/>
+                <a:spcPct val="135000"/>
               </a:lnSpc>
             </a:pPr>
             <a:r>
@@ -17567,7 +17663,7 @@
           <a:p>
             <a:pPr algn="l">
               <a:lnSpc>
-                <a:spcPct val="120000"/>
+                <a:spcPct val="135000"/>
               </a:lnSpc>
             </a:pPr>
             <a:r>
@@ -17619,7 +17715,7 @@
           <a:p>
             <a:pPr algn="l">
               <a:lnSpc>
-                <a:spcPct val="120000"/>
+                <a:spcPct val="135000"/>
               </a:lnSpc>
             </a:pPr>
             <a:r>
@@ -17680,7 +17776,7 @@
           <a:p>
             <a:pPr algn="l">
               <a:lnSpc>
-                <a:spcPct val="120000"/>
+                <a:spcPct val="135000"/>
               </a:lnSpc>
             </a:pPr>
             <a:r>
@@ -17696,7 +17792,7 @@
           <a:p>
             <a:pPr algn="l">
               <a:lnSpc>
-                <a:spcPct val="120000"/>
+                <a:spcPct val="135000"/>
               </a:lnSpc>
             </a:pPr>
             <a:r>
@@ -17720,7 +17816,7 @@
         <p:spPr>
           <a:xfrm>
             <a:off x="822960" y="4114800"/>
-            <a:ext cx="10515600" cy="1737360"/>
+            <a:ext cx="10515600" cy="1828800"/>
           </a:xfrm>
           <a:prstGeom prst="rect">
             <a:avLst/>
@@ -17798,7 +17894,7 @@
         </p:nvSpPr>
         <p:spPr>
           <a:xfrm>
-            <a:off x="1097280" y="4251960"/>
+            <a:off x="1097280" y="4297680"/>
             <a:ext cx="10149840" cy="1554480"/>
           </a:xfrm>
           <a:prstGeom prst="rect">
@@ -17814,7 +17910,7 @@
           <a:p>
             <a:pPr algn="l">
               <a:lnSpc>
-                <a:spcPct val="120000"/>
+                <a:spcPct val="135000"/>
               </a:lnSpc>
             </a:pPr>
             <a:r>
@@ -17866,11 +17962,11 @@
           <a:p>
             <a:pPr algn="l">
               <a:lnSpc>
-                <a:spcPct val="120000"/>
+                <a:spcPct val="135000"/>
               </a:lnSpc>
             </a:pPr>
             <a:r>
-              <a:rPr sz="500" b="0" i="0">
+              <a:rPr sz="1200" b="0" i="0">
                 <a:solidFill>
                   <a:srgbClr val="1C1917"/>
                 </a:solidFill>
@@ -17882,7 +17978,7 @@
           <a:p>
             <a:pPr algn="l">
               <a:lnSpc>
-                <a:spcPct val="120000"/>
+                <a:spcPct val="135000"/>
               </a:lnSpc>
             </a:pPr>
             <a:r>
@@ -17975,7 +18071,7 @@
           <a:p>
             <a:pPr algn="ctr">
               <a:lnSpc>
-                <a:spcPct val="115000"/>
+                <a:spcPct val="130000"/>
               </a:lnSpc>
             </a:pPr>
             <a:r>
@@ -18014,7 +18110,7 @@
           <a:p>
             <a:pPr algn="l">
               <a:lnSpc>
-                <a:spcPct val="115000"/>
+                <a:spcPct val="130000"/>
               </a:lnSpc>
             </a:pPr>
             <a:r>

</xml_diff>